<commit_message>
added 4d cell image
</commit_message>
<xml_diff>
--- a/Lecture4/IntroProgrammingPart4.pptx
+++ b/Lecture4/IntroProgrammingPart4.pptx
@@ -6841,10 +6841,10 @@
       </p:grpSpPr>
       <p:pic>
         <p:nvPicPr>
-          <p:cNvPr id="6" name="Picture 5">
-            <a:extLst>
-              <a:ext uri="{FF2B5EF4-FFF2-40B4-BE49-F238E27FC236}">
-                <a16:creationId xmlns:a16="http://schemas.microsoft.com/office/drawing/2014/main" id="{852BD599-E5E7-F42C-D523-2B3058DFF8DF}"/>
+          <p:cNvPr id="3" name="Picture 2" descr="graphic shows a cartoon of a cell dividing.">
+            <a:extLst>
+              <a:ext uri="{FF2B5EF4-FFF2-40B4-BE49-F238E27FC236}">
+                <a16:creationId xmlns:a16="http://schemas.microsoft.com/office/drawing/2014/main" id="{C0A380ED-BFAD-5DD2-C3E3-C0B54141E9A1}"/>
               </a:ext>
             </a:extLst>
           </p:cNvPr>
@@ -6855,6 +6855,36 @@
         </p:nvPicPr>
         <p:blipFill>
           <a:blip r:embed="rId2"/>
+          <a:stretch>
+            <a:fillRect/>
+          </a:stretch>
+        </p:blipFill>
+        <p:spPr>
+          <a:xfrm>
+            <a:off x="2209800" y="685879"/>
+            <a:ext cx="7772400" cy="4895248"/>
+          </a:xfrm>
+          <a:prstGeom prst="rect">
+            <a:avLst/>
+          </a:prstGeom>
+        </p:spPr>
+      </p:pic>
+      <p:pic>
+        <p:nvPicPr>
+          <p:cNvPr id="6" name="Picture 5">
+            <a:extLst>
+              <a:ext uri="{FF2B5EF4-FFF2-40B4-BE49-F238E27FC236}">
+                <a16:creationId xmlns:a16="http://schemas.microsoft.com/office/drawing/2014/main" id="{852BD599-E5E7-F42C-D523-2B3058DFF8DF}"/>
+              </a:ext>
+            </a:extLst>
+          </p:cNvPr>
+          <p:cNvPicPr>
+            <a:picLocks noChangeAspect="1"/>
+          </p:cNvPicPr>
+          <p:nvPr/>
+        </p:nvPicPr>
+        <p:blipFill>
+          <a:blip r:embed="rId3"/>
           <a:stretch>
             <a:fillRect/>
           </a:stretch>
@@ -6884,7 +6914,7 @@
           <p:nvPr/>
         </p:nvPicPr>
         <p:blipFill>
-          <a:blip r:embed="rId3"/>
+          <a:blip r:embed="rId4"/>
           <a:srcRect b="63556"/>
           <a:stretch>
             <a:fillRect/>
@@ -6915,7 +6945,7 @@
           <p:nvPr/>
         </p:nvPicPr>
         <p:blipFill>
-          <a:blip r:embed="rId4"/>
+          <a:blip r:embed="rId5"/>
           <a:stretch>
             <a:fillRect/>
           </a:stretch>
@@ -6987,7 +7017,7 @@
         </p:nvSpPr>
         <p:spPr>
           <a:xfrm>
-            <a:off x="3490318" y="3126597"/>
+            <a:off x="-80563" y="6253195"/>
             <a:ext cx="5211363" cy="369332"/>
           </a:xfrm>
           <a:prstGeom prst="rect">
@@ -7003,31 +7033,31 @@
           <a:p>
             <a:r>
               <a:rPr lang="en-US" dirty="0">
-                <a:hlinkClick r:id="rId5"/>
+                <a:hlinkClick r:id="rId6"/>
               </a:rPr>
               <a:t>https://</a:t>
             </a:r>
             <a:r>
               <a:rPr lang="en-US" dirty="0" err="1">
-                <a:hlinkClick r:id="rId5"/>
+                <a:hlinkClick r:id="rId6"/>
               </a:rPr>
               <a:t>www.youtube.com</a:t>
             </a:r>
             <a:r>
               <a:rPr lang="en-US" dirty="0">
-                <a:hlinkClick r:id="rId5"/>
+                <a:hlinkClick r:id="rId6"/>
               </a:rPr>
               <a:t>/</a:t>
             </a:r>
             <a:r>
               <a:rPr lang="en-US" dirty="0" err="1">
-                <a:hlinkClick r:id="rId5"/>
+                <a:hlinkClick r:id="rId6"/>
               </a:rPr>
               <a:t>watch?v</a:t>
             </a:r>
             <a:r>
               <a:rPr lang="en-US" dirty="0">
-                <a:hlinkClick r:id="rId5"/>
+                <a:hlinkClick r:id="rId6"/>
               </a:rPr>
               <a:t>=EQ2ywYhYs5Y</a:t>
             </a:r>
@@ -7049,7 +7079,7 @@
         </p:nvSpPr>
         <p:spPr>
           <a:xfrm>
-            <a:off x="3501635" y="3382267"/>
+            <a:off x="-69246" y="6508865"/>
             <a:ext cx="5188728" cy="369332"/>
           </a:xfrm>
           <a:prstGeom prst="rect">
@@ -7065,7 +7095,7 @@
           <a:p>
             <a:r>
               <a:rPr lang="en-US" dirty="0">
-                <a:hlinkClick r:id="rId6"/>
+                <a:hlinkClick r:id="rId7"/>
               </a:rPr>
               <a:t>https://www.youtube.com/watch?v=9JhVKu4GEA8</a:t>
             </a:r>

</xml_diff>